<commit_message>
Fix corrupt PPTX: avoid duplicate effectLst on shadowed shapes
shadow.inherit=False already inserts an empty <a:effectLst>; the code
then appended a second one with the outerShdw, producing two effectLst
children per shape. That is invalid OOXML and made PowerPoint refuse to
open the file ("needs repair"). Now reuse the existing effectLst and add
the shadow into it. Validated: no duplicate effectLst, ln/pPr child
ordering schema-correct.

Co-Authored-By: Claude Opus 4.8 <noreply@anthropic.com>
Claude-Session: https://claude.ai/code/session_01TnGQWrNTiKf6GTrCxVquqV
</commit_message>
<xml_diff>
--- a/AI_Chat_Architecture_BangkokBank.pptx
+++ b/AI_Chat_Architecture_BangkokBank.pptx
@@ -3420,7 +3420,6 @@
           <a:ln>
             <a:noFill/>
           </a:ln>
-          <a:effectLst/>
           <a:effectLst>
             <a:outerShdw blurRad="60000" dist="30000" dir="5400000" rotWithShape="0">
               <a:srgbClr val="1A2230">
@@ -3528,7 +3527,6 @@
           <a:ln>
             <a:noFill/>
           </a:ln>
-          <a:effectLst/>
           <a:effectLst>
             <a:outerShdw blurRad="60000" dist="30000" dir="5400000" rotWithShape="0">
               <a:srgbClr val="1A2230">
@@ -3636,7 +3634,6 @@
           <a:ln>
             <a:noFill/>
           </a:ln>
-          <a:effectLst/>
           <a:effectLst>
             <a:outerShdw blurRad="60000" dist="30000" dir="5400000" rotWithShape="0">
               <a:srgbClr val="1A2230">
@@ -3744,7 +3741,6 @@
           <a:ln>
             <a:noFill/>
           </a:ln>
-          <a:effectLst/>
           <a:effectLst>
             <a:outerShdw blurRad="60000" dist="30000" dir="5400000" rotWithShape="0">
               <a:srgbClr val="1A2230">
@@ -3812,7 +3808,6 @@
           <a:ln>
             <a:noFill/>
           </a:ln>
-          <a:effectLst/>
           <a:effectLst>
             <a:outerShdw blurRad="60000" dist="30000" dir="5400000" rotWithShape="0">
               <a:srgbClr val="1A2230">
@@ -4441,7 +4436,6 @@
           <a:ln>
             <a:noFill/>
           </a:ln>
-          <a:effectLst/>
           <a:effectLst>
             <a:outerShdw blurRad="60000" dist="30000" dir="5400000" rotWithShape="0">
               <a:srgbClr val="1A2230">
@@ -4553,7 +4547,6 @@
               <a:srgbClr val="1A9C9C"/>
             </a:solidFill>
           </a:ln>
-          <a:effectLst/>
           <a:effectLst>
             <a:outerShdw blurRad="60000" dist="30000" dir="5400000" rotWithShape="0">
               <a:srgbClr val="1A2230">
@@ -4887,7 +4880,6 @@
           <a:ln>
             <a:noFill/>
           </a:ln>
-          <a:effectLst/>
           <a:effectLst>
             <a:outerShdw blurRad="60000" dist="30000" dir="5400000" rotWithShape="0">
               <a:srgbClr val="1A2230">
@@ -5188,7 +5180,6 @@
           <a:ln>
             <a:noFill/>
           </a:ln>
-          <a:effectLst/>
           <a:effectLst>
             <a:outerShdw blurRad="60000" dist="30000" dir="5400000" rotWithShape="0">
               <a:srgbClr val="1A2230">
@@ -5296,7 +5287,6 @@
           <a:ln>
             <a:noFill/>
           </a:ln>
-          <a:effectLst/>
           <a:effectLst>
             <a:outerShdw blurRad="60000" dist="30000" dir="5400000" rotWithShape="0">
               <a:srgbClr val="1A2230">
@@ -6489,7 +6479,6 @@
           <a:ln>
             <a:noFill/>
           </a:ln>
-          <a:effectLst/>
           <a:effectLst>
             <a:outerShdw blurRad="60000" dist="30000" dir="5400000" rotWithShape="0">
               <a:srgbClr val="1A2230">
@@ -6668,7 +6657,6 @@
           <a:ln>
             <a:noFill/>
           </a:ln>
-          <a:effectLst/>
           <a:effectLst>
             <a:outerShdw blurRad="60000" dist="30000" dir="5400000" rotWithShape="0">
               <a:srgbClr val="1A2230">
@@ -6847,7 +6835,6 @@
           <a:ln>
             <a:noFill/>
           </a:ln>
-          <a:effectLst/>
           <a:effectLst>
             <a:outerShdw blurRad="60000" dist="30000" dir="5400000" rotWithShape="0">
               <a:srgbClr val="1A2230">
@@ -7026,7 +7013,6 @@
           <a:ln>
             <a:noFill/>
           </a:ln>
-          <a:effectLst/>
           <a:effectLst>
             <a:outerShdw blurRad="60000" dist="30000" dir="5400000" rotWithShape="0">
               <a:srgbClr val="1A2230">
@@ -7205,7 +7191,6 @@
           <a:ln>
             <a:noFill/>
           </a:ln>
-          <a:effectLst/>
           <a:effectLst>
             <a:outerShdw blurRad="60000" dist="30000" dir="5400000" rotWithShape="0">
               <a:srgbClr val="1A2230">
@@ -7384,7 +7369,6 @@
           <a:ln>
             <a:noFill/>
           </a:ln>
-          <a:effectLst/>
           <a:effectLst>
             <a:outerShdw blurRad="60000" dist="30000" dir="5400000" rotWithShape="0">
               <a:srgbClr val="1A2230">
@@ -7563,7 +7547,6 @@
           <a:ln>
             <a:noFill/>
           </a:ln>
-          <a:effectLst/>
           <a:effectLst>
             <a:outerShdw blurRad="60000" dist="30000" dir="5400000" rotWithShape="0">
               <a:srgbClr val="1A2230">
@@ -7742,7 +7725,6 @@
           <a:ln>
             <a:noFill/>
           </a:ln>
-          <a:effectLst/>
           <a:effectLst>
             <a:outerShdw blurRad="60000" dist="30000" dir="5400000" rotWithShape="0">
               <a:srgbClr val="1A2230">
@@ -7921,7 +7903,6 @@
           <a:ln>
             <a:noFill/>
           </a:ln>
-          <a:effectLst/>
           <a:effectLst>
             <a:outerShdw blurRad="60000" dist="30000" dir="5400000" rotWithShape="0">
               <a:srgbClr val="1A2230">
@@ -8100,7 +8081,6 @@
           <a:ln>
             <a:noFill/>
           </a:ln>
-          <a:effectLst/>
           <a:effectLst>
             <a:outerShdw blurRad="60000" dist="30000" dir="5400000" rotWithShape="0">
               <a:srgbClr val="1A2230">
@@ -8279,7 +8259,6 @@
           <a:ln>
             <a:noFill/>
           </a:ln>
-          <a:effectLst/>
           <a:effectLst>
             <a:outerShdw blurRad="60000" dist="30000" dir="5400000" rotWithShape="0">
               <a:srgbClr val="1A2230">
@@ -8896,7 +8875,6 @@
               <a:srgbClr val="C0393D"/>
             </a:solidFill>
           </a:ln>
-          <a:effectLst/>
           <a:effectLst>
             <a:outerShdw blurRad="60000" dist="30000" dir="5400000" rotWithShape="0">
               <a:srgbClr val="1A2230">
@@ -9570,7 +9548,6 @@
               <a:srgbClr val="C9A227"/>
             </a:solidFill>
           </a:ln>
-          <a:effectLst/>
           <a:effectLst>
             <a:outerShdw blurRad="60000" dist="30000" dir="5400000" rotWithShape="0">
               <a:srgbClr val="1A2230">
@@ -10244,7 +10221,6 @@
               <a:srgbClr val="2E9E5B"/>
             </a:solidFill>
           </a:ln>
-          <a:effectLst/>
           <a:effectLst>
             <a:outerShdw blurRad="60000" dist="30000" dir="5400000" rotWithShape="0">
               <a:srgbClr val="1A2230">
@@ -11292,7 +11268,6 @@
           <a:ln>
             <a:noFill/>
           </a:ln>
-          <a:effectLst/>
           <a:effectLst>
             <a:outerShdw blurRad="60000" dist="30000" dir="5400000" rotWithShape="0">
               <a:srgbClr val="1A2230">
@@ -11400,7 +11375,6 @@
           <a:ln>
             <a:noFill/>
           </a:ln>
-          <a:effectLst/>
           <a:effectLst>
             <a:outerShdw blurRad="60000" dist="30000" dir="5400000" rotWithShape="0">
               <a:srgbClr val="1A2230">
@@ -11508,7 +11482,6 @@
           <a:ln>
             <a:noFill/>
           </a:ln>
-          <a:effectLst/>
           <a:effectLst>
             <a:outerShdw blurRad="60000" dist="30000" dir="5400000" rotWithShape="0">
               <a:srgbClr val="1A2230">
@@ -11616,7 +11589,6 @@
           <a:ln>
             <a:noFill/>
           </a:ln>
-          <a:effectLst/>
           <a:effectLst>
             <a:outerShdw blurRad="60000" dist="30000" dir="5400000" rotWithShape="0">
               <a:srgbClr val="1A2230">
@@ -11684,7 +11656,6 @@
           <a:ln>
             <a:noFill/>
           </a:ln>
-          <a:effectLst/>
           <a:effectLst>
             <a:outerShdw blurRad="60000" dist="30000" dir="5400000" rotWithShape="0">
               <a:srgbClr val="1A2230">

</xml_diff>